<commit_message>
Updates to Overview figure
</commit_message>
<xml_diff>
--- a/icra-competition-2026/Overview.pptx
+++ b/icra-competition-2026/Overview.pptx
@@ -104,6 +104,11 @@
       </a:defRPr>
     </a:lvl9pPr>
   </p:defaultTextStyle>
+  <p:extLst>
+    <p:ext uri="{EFAFB233-063F-42B5-8137-9DF3F51BA10A}">
+      <p15:sldGuideLst xmlns:p15="http://schemas.microsoft.com/office/powerpoint/2012/main"/>
+    </p:ext>
+  </p:extLst>
 </p:presentation>
 </file>
 
@@ -3336,7 +3341,7 @@
         <p:spPr>
           <a:xfrm>
             <a:off x="351692" y="446259"/>
-            <a:ext cx="4814715" cy="400110"/>
+            <a:ext cx="4851571" cy="400110"/>
           </a:xfrm>
           <a:prstGeom prst="rect">
             <a:avLst/>
@@ -3378,8 +3383,8 @@
         </p:nvSpPr>
         <p:spPr>
           <a:xfrm>
-            <a:off x="5776373" y="445893"/>
-            <a:ext cx="4754880" cy="400110"/>
+            <a:off x="5776372" y="445893"/>
+            <a:ext cx="4846015" cy="400110"/>
           </a:xfrm>
           <a:prstGeom prst="rect">
             <a:avLst/>
@@ -3479,7 +3484,7 @@
                 <a:latin typeface="Arial" panose="020B0604020202020204" pitchFamily="34" charset="0"/>
                 <a:cs typeface="Arial" panose="020B0604020202020204" pitchFamily="34" charset="0"/>
               </a:rPr>
-              <a:t>No experience or preparation needed!</a:t>
+              <a:t>No experience or preparation needed</a:t>
             </a:r>
           </a:p>
         </p:txBody>
@@ -3513,7 +3518,7 @@
         </p:blipFill>
         <p:spPr bwMode="auto">
           <a:xfrm flipH="1">
-            <a:off x="987146" y="2218706"/>
+            <a:off x="797889" y="2210140"/>
             <a:ext cx="1280903" cy="1280903"/>
           </a:xfrm>
           <a:prstGeom prst="rect">
@@ -3559,7 +3564,7 @@
         </p:blipFill>
         <p:spPr>
           <a:xfrm>
-            <a:off x="2945092" y="2042388"/>
+            <a:off x="2846345" y="2022292"/>
             <a:ext cx="1700341" cy="1470796"/>
           </a:xfrm>
           <a:prstGeom prst="rect">
@@ -3581,8 +3586,8 @@
         </p:nvSpPr>
         <p:spPr>
           <a:xfrm>
-            <a:off x="769902" y="4002486"/>
-            <a:ext cx="4170026" cy="584775"/>
+            <a:off x="346440" y="3982390"/>
+            <a:ext cx="4851571" cy="584775"/>
           </a:xfrm>
           <a:prstGeom prst="rect">
             <a:avLst/>
@@ -3614,21 +3619,21 @@
                 <a:latin typeface="Arial" panose="020B0604020202020204" pitchFamily="34" charset="0"/>
                 <a:cs typeface="Arial" panose="020B0604020202020204" pitchFamily="34" charset="0"/>
               </a:rPr>
-              <a:t>to teleoperate this </a:t>
+              <a:t>to teleoperate two of these </a:t>
             </a:r>
             <a:r>
               <a:rPr lang="en-US" sz="1600" u="sng" dirty="0">
                 <a:latin typeface="Arial" panose="020B0604020202020204" pitchFamily="34" charset="0"/>
                 <a:cs typeface="Arial" panose="020B0604020202020204" pitchFamily="34" charset="0"/>
               </a:rPr>
-              <a:t>robot </a:t>
+              <a:t>robots</a:t>
             </a:r>
             <a:r>
               <a:rPr lang="en-US" sz="1600" dirty="0">
                 <a:latin typeface="Arial" panose="020B0604020202020204" pitchFamily="34" charset="0"/>
                 <a:cs typeface="Arial" panose="020B0604020202020204" pitchFamily="34" charset="0"/>
               </a:rPr>
-              <a:t>to perform this </a:t>
+              <a:t> to perform this </a:t>
             </a:r>
             <a:r>
               <a:rPr lang="en-US" sz="1600" u="sng" dirty="0">
@@ -3636,6 +3641,13 @@
                 <a:cs typeface="Arial" panose="020B0604020202020204" pitchFamily="34" charset="0"/>
               </a:rPr>
               <a:t>task</a:t>
+            </a:r>
+            <a:r>
+              <a:rPr lang="en-US" sz="1600" dirty="0">
+                <a:latin typeface="Arial" panose="020B0604020202020204" pitchFamily="34" charset="0"/>
+                <a:cs typeface="Arial" panose="020B0604020202020204" pitchFamily="34" charset="0"/>
+              </a:rPr>
+              <a:t> (real or sim)</a:t>
             </a:r>
             <a:endParaRPr lang="en-US" sz="1100" u="sng" dirty="0">
               <a:latin typeface="Arial" panose="020B0604020202020204" pitchFamily="34" charset="0"/>
@@ -3660,7 +3672,7 @@
         </p:nvCxnSpPr>
         <p:spPr>
           <a:xfrm flipV="1">
-            <a:off x="1818515" y="3582967"/>
+            <a:off x="1486919" y="3562871"/>
             <a:ext cx="0" cy="419519"/>
           </a:xfrm>
           <a:prstGeom prst="straightConnector1">
@@ -3701,8 +3713,8 @@
         </p:nvCxnSpPr>
         <p:spPr>
           <a:xfrm flipH="1" flipV="1">
-            <a:off x="3688888" y="3613648"/>
-            <a:ext cx="289948" cy="399929"/>
+            <a:off x="4049486" y="3491043"/>
+            <a:ext cx="286349" cy="469703"/>
           </a:xfrm>
           <a:prstGeom prst="straightConnector1">
             <a:avLst/>
@@ -3817,8 +3829,8 @@
         </p:nvSpPr>
         <p:spPr>
           <a:xfrm>
-            <a:off x="6007974" y="4002486"/>
-            <a:ext cx="4362548" cy="584775"/>
+            <a:off x="5771121" y="3982390"/>
+            <a:ext cx="4851267" cy="584775"/>
           </a:xfrm>
           <a:prstGeom prst="rect">
             <a:avLst/>
@@ -3850,21 +3862,21 @@
                 <a:latin typeface="Arial" panose="020B0604020202020204" pitchFamily="34" charset="0"/>
                 <a:cs typeface="Arial" panose="020B0604020202020204" pitchFamily="34" charset="0"/>
               </a:rPr>
-              <a:t> to get this </a:t>
+              <a:t> for two of these </a:t>
             </a:r>
             <a:r>
               <a:rPr lang="en-US" sz="1600" u="sng" dirty="0">
                 <a:latin typeface="Arial" panose="020B0604020202020204" pitchFamily="34" charset="0"/>
                 <a:cs typeface="Arial" panose="020B0604020202020204" pitchFamily="34" charset="0"/>
               </a:rPr>
-              <a:t>robot </a:t>
+              <a:t>robots</a:t>
             </a:r>
             <a:r>
               <a:rPr lang="en-US" sz="1600" dirty="0">
                 <a:latin typeface="Arial" panose="020B0604020202020204" pitchFamily="34" charset="0"/>
                 <a:cs typeface="Arial" panose="020B0604020202020204" pitchFamily="34" charset="0"/>
               </a:rPr>
-              <a:t>to autonomously perform this </a:t>
+              <a:t> to autonomously perform this </a:t>
             </a:r>
             <a:r>
               <a:rPr lang="en-US" sz="1600" u="sng" dirty="0">
@@ -3872,6 +3884,13 @@
                 <a:cs typeface="Arial" panose="020B0604020202020204" pitchFamily="34" charset="0"/>
               </a:rPr>
               <a:t>task</a:t>
+            </a:r>
+            <a:r>
+              <a:rPr lang="en-US" sz="1600" dirty="0">
+                <a:latin typeface="Arial" panose="020B0604020202020204" pitchFamily="34" charset="0"/>
+                <a:cs typeface="Arial" panose="020B0604020202020204" pitchFamily="34" charset="0"/>
+              </a:rPr>
+              <a:t> (real or sim)</a:t>
             </a:r>
             <a:endParaRPr lang="en-US" sz="1100" u="sng" dirty="0">
               <a:latin typeface="Arial" panose="020B0604020202020204" pitchFamily="34" charset="0"/>
@@ -3908,7 +3927,7 @@
         </p:blipFill>
         <p:spPr>
           <a:xfrm>
-            <a:off x="8227801" y="2042388"/>
+            <a:off x="8172818" y="2022292"/>
             <a:ext cx="1681821" cy="1454775"/>
           </a:xfrm>
           <a:prstGeom prst="rect">
@@ -3932,8 +3951,8 @@
         </p:nvCxnSpPr>
         <p:spPr>
           <a:xfrm flipV="1">
-            <a:off x="8326216" y="3582967"/>
-            <a:ext cx="348118" cy="462517"/>
+            <a:off x="8674334" y="3562871"/>
+            <a:ext cx="0" cy="369552"/>
           </a:xfrm>
           <a:prstGeom prst="straightConnector1">
             <a:avLst/>
@@ -3971,8 +3990,8 @@
         </p:nvSpPr>
         <p:spPr>
           <a:xfrm>
-            <a:off x="6179013" y="2533726"/>
-            <a:ext cx="580568" cy="714574"/>
+            <a:off x="6385325" y="2513630"/>
+            <a:ext cx="764119" cy="714574"/>
           </a:xfrm>
           <a:prstGeom prst="can">
             <a:avLst/>
@@ -4006,7 +4025,7 @@
           <a:p>
             <a:pPr algn="ctr"/>
             <a:r>
-              <a:rPr lang="en-US" sz="1600" dirty="0"/>
+              <a:rPr lang="en-US" dirty="0"/>
               <a:t>Data</a:t>
             </a:r>
           </a:p>
@@ -4040,7 +4059,7 @@
         </p:blipFill>
         <p:spPr>
           <a:xfrm>
-            <a:off x="2903205" y="4560870"/>
+            <a:off x="2903205" y="4580966"/>
             <a:ext cx="1891862" cy="1145020"/>
           </a:xfrm>
           <a:prstGeom prst="rect">
@@ -4076,7 +4095,7 @@
         </p:blipFill>
         <p:spPr>
           <a:xfrm>
-            <a:off x="8187703" y="4560870"/>
+            <a:off x="8187703" y="4580966"/>
             <a:ext cx="1979316" cy="1197950"/>
           </a:xfrm>
           <a:prstGeom prst="rect">
@@ -4102,11 +4121,13 @@
         </p:nvCxnSpPr>
         <p:spPr>
           <a:xfrm flipV="1">
-            <a:off x="4795067" y="2891013"/>
-            <a:ext cx="1383946" cy="2242367"/>
+            <a:off x="4795067" y="2870917"/>
+            <a:ext cx="1590258" cy="2282559"/>
           </a:xfrm>
           <a:prstGeom prst="bentConnector3">
-            <a:avLst/>
+            <a:avLst>
+              <a:gd name="adj1" fmla="val 45577"/>
+            </a:avLst>
           </a:prstGeom>
           <a:ln>
             <a:prstDash val="dash"/>
@@ -4144,9 +4165,9 @@
           <p:nvPr/>
         </p:nvCxnSpPr>
         <p:spPr>
-          <a:xfrm>
-            <a:off x="6469297" y="3248300"/>
-            <a:ext cx="488944" cy="797184"/>
+          <a:xfrm flipH="1">
+            <a:off x="6762490" y="3228204"/>
+            <a:ext cx="4895" cy="754186"/>
           </a:xfrm>
           <a:prstGeom prst="straightConnector1">
             <a:avLst/>
@@ -4188,8 +4209,8 @@
         </p:nvCxnSpPr>
         <p:spPr>
           <a:xfrm rot="16200000" flipH="1">
-            <a:off x="2261249" y="4491423"/>
-            <a:ext cx="557303" cy="726609"/>
+            <a:off x="2030145" y="4280415"/>
+            <a:ext cx="597495" cy="1148625"/>
           </a:xfrm>
           <a:prstGeom prst="bentConnector2">
             <a:avLst/>
@@ -4227,7 +4248,7 @@
         </p:nvSpPr>
         <p:spPr>
           <a:xfrm>
-            <a:off x="1964693" y="4300695"/>
+            <a:off x="1542677" y="4280599"/>
             <a:ext cx="423806" cy="275382"/>
           </a:xfrm>
           <a:prstGeom prst="rect">
@@ -4281,8 +4302,8 @@
         </p:nvCxnSpPr>
         <p:spPr>
           <a:xfrm rot="16200000" flipH="1">
-            <a:off x="7487625" y="4459767"/>
-            <a:ext cx="586398" cy="813757"/>
+            <a:off x="7377097" y="4369335"/>
+            <a:ext cx="626590" cy="994621"/>
           </a:xfrm>
           <a:prstGeom prst="bentConnector2">
             <a:avLst/>
@@ -4320,7 +4341,7 @@
         </p:nvSpPr>
         <p:spPr>
           <a:xfrm>
-            <a:off x="7174524" y="4240402"/>
+            <a:off x="6993660" y="4220306"/>
             <a:ext cx="398843" cy="333045"/>
           </a:xfrm>
           <a:prstGeom prst="rect">
@@ -4370,8 +4391,8 @@
         </p:nvSpPr>
         <p:spPr>
           <a:xfrm>
-            <a:off x="1008846" y="5727534"/>
-            <a:ext cx="3898761" cy="369332"/>
+            <a:off x="346440" y="5727534"/>
+            <a:ext cx="4846320" cy="369332"/>
           </a:xfrm>
           <a:prstGeom prst="rect">
             <a:avLst/>
@@ -4384,6 +4405,7 @@
           </a:bodyPr>
           <a:lstStyle/>
           <a:p>
+            <a:pPr algn="ctr"/>
             <a:r>
               <a:rPr lang="en-US" i="1" dirty="0">
                 <a:latin typeface="Arial" panose="020B0604020202020204" pitchFamily="34" charset="0"/>
@@ -4415,7 +4437,7 @@
         </p:nvSpPr>
         <p:spPr>
           <a:xfrm>
-            <a:off x="4817175" y="5147999"/>
+            <a:off x="4817175" y="5127903"/>
             <a:ext cx="415608" cy="369332"/>
           </a:xfrm>
           <a:prstGeom prst="rect">
@@ -4454,7 +4476,7 @@
         <p:spPr>
           <a:xfrm>
             <a:off x="351692" y="432079"/>
-            <a:ext cx="4754880" cy="5669280"/>
+            <a:ext cx="4846320" cy="5669280"/>
           </a:xfrm>
           <a:prstGeom prst="roundRect">
             <a:avLst/>
@@ -4503,8 +4525,8 @@
         </p:nvSpPr>
         <p:spPr>
           <a:xfrm>
-            <a:off x="5776373" y="432079"/>
-            <a:ext cx="4754880" cy="5669280"/>
+            <a:off x="5776372" y="432079"/>
+            <a:ext cx="4846016" cy="5669280"/>
           </a:xfrm>
           <a:prstGeom prst="roundRect">
             <a:avLst/>

</xml_diff>

<commit_message>
Minor update to Overview figure
</commit_message>
<xml_diff>
--- a/icra-competition-2026/Overview.pptx
+++ b/icra-competition-2026/Overview.pptx
@@ -3714,7 +3714,7 @@
         <p:spPr>
           <a:xfrm flipH="1" flipV="1">
             <a:off x="4049486" y="3491043"/>
-            <a:ext cx="286349" cy="469703"/>
+            <a:ext cx="391885" cy="491347"/>
           </a:xfrm>
           <a:prstGeom prst="straightConnector1">
             <a:avLst/>
@@ -3952,7 +3952,7 @@
         <p:spPr>
           <a:xfrm flipV="1">
             <a:off x="8674334" y="3562871"/>
-            <a:ext cx="0" cy="369552"/>
+            <a:ext cx="0" cy="457200"/>
           </a:xfrm>
           <a:prstGeom prst="straightConnector1">
             <a:avLst/>

</xml_diff>

<commit_message>
Removed one blue peg from Overview
</commit_message>
<xml_diff>
--- a/icra-competition-2026/Overview.pptx
+++ b/icra-competition-2026/Overview.pptx
@@ -4053,14 +4053,13 @@
               </a:ext>
             </a:extLst>
           </a:blip>
-          <a:stretch>
-            <a:fillRect/>
-          </a:stretch>
+          <a:srcRect/>
+          <a:stretch/>
         </p:blipFill>
         <p:spPr>
           <a:xfrm>
             <a:off x="2903205" y="4580966"/>
-            <a:ext cx="1891862" cy="1145020"/>
+            <a:ext cx="1891861" cy="1145020"/>
           </a:xfrm>
           <a:prstGeom prst="rect">
             <a:avLst/>
@@ -4089,14 +4088,13 @@
               </a:ext>
             </a:extLst>
           </a:blip>
-          <a:stretch>
-            <a:fillRect/>
-          </a:stretch>
+          <a:srcRect/>
+          <a:stretch/>
         </p:blipFill>
         <p:spPr>
           <a:xfrm>
             <a:off x="8187703" y="4580966"/>
-            <a:ext cx="1979316" cy="1197950"/>
+            <a:ext cx="1979315" cy="1197950"/>
           </a:xfrm>
           <a:prstGeom prst="rect">
             <a:avLst/>

</xml_diff>

<commit_message>
Added another registration link
</commit_message>
<xml_diff>
--- a/icra-competition-2026/Overview.pptx
+++ b/icra-competition-2026/Overview.pptx
@@ -3451,7 +3451,7 @@
           </a:fontRef>
         </p:style>
         <p:txBody>
-          <a:bodyPr rtlCol="0" anchor="ctr"/>
+          <a:bodyPr bIns="91440" rtlCol="0" anchor="ctr" anchorCtr="1"/>
           <a:lstStyle/>
           <a:p>
             <a:pPr>
@@ -3777,7 +3777,7 @@
           </a:fontRef>
         </p:style>
         <p:txBody>
-          <a:bodyPr rtlCol="0" anchor="ctr"/>
+          <a:bodyPr bIns="91440" rtlCol="0" anchor="ctr" anchorCtr="1"/>
           <a:lstStyle/>
           <a:p>
             <a:pPr>
@@ -3810,7 +3810,7 @@
                 <a:latin typeface="Arial" panose="020B0604020202020204" pitchFamily="34" charset="0"/>
                 <a:cs typeface="Arial" panose="020B0604020202020204" pitchFamily="34" charset="0"/>
               </a:rPr>
-              <a:t>Registration required (see website)</a:t>
+              <a:t>Registration required (see below)</a:t>
             </a:r>
           </a:p>
         </p:txBody>

</xml_diff>